<commit_message>
Mention solutions/ folder on each exercise slide
Adds a bullet to the Exercise 1/2/3 slides pointing to the completed reference implementation in solutions/<language>/ for attendees who get stuck.

Co-Authored-By: Claude Sonnet 5 <noreply@anthropic.com>
</commit_message>
<xml_diff>
--- a/TDD_with_AI_Workshop.pptx
+++ b/TDD_with_AI_Workshop.pptx
@@ -7218,6 +7218,14 @@
               <a:defRPr sz="1800"/>
             </a:pPr>
             <a:r>
+              <a:t>Reference Solution: solutions/&lt;language&gt;/exercise3/ has a completed refactor, commented per test, if you get stuck.</a:t>
+            </a:r>
+          </a:p>
+          <a:p>
+            <a:pPr>
+              <a:defRPr sz="1800"/>
+            </a:pPr>
+            <a:r>
               <a:t>Target Duration: 40 Minutes.</a:t>
             </a:r>
           </a:p>
@@ -7814,6 +7822,14 @@
               <a:defRPr sz="1800"/>
             </a:pPr>
             <a:r>
+              <a:t>Reference Solution: solutions/&lt;language&gt;/exercise1/ has a completed implementation, commented per test, if you get stuck.</a:t>
+            </a:r>
+          </a:p>
+          <a:p>
+            <a:pPr>
+              <a:defRPr sz="1800"/>
+            </a:pPr>
+            <a:r>
               <a:t>Target Duration: 45 Minutes.</a:t>
             </a:r>
           </a:p>
@@ -8011,6 +8027,14 @@
             </a:pPr>
             <a:r>
               <a:t>Step 4 (Verification): Reach 100% Green with clean, readable code and zero structural bloat.</a:t>
+            </a:r>
+          </a:p>
+          <a:p>
+            <a:pPr>
+              <a:defRPr sz="1800"/>
+            </a:pPr>
+            <a:r>
+              <a:t>Reference Solution: solutions/&lt;language&gt;/exercise2/ has a completed implementation, commented per test, if you get stuck.</a:t>
             </a:r>
           </a:p>
           <a:p>

</xml_diff>